<commit_message>
Slide baseline: tiêu đề nêu thẳng kết quả, bỏ cách diễn đạt sáo
- Slide 5 và 7 đổi từ tiêu đề mô tả sang tiêu đề nêu kết luận:
  "Năm loại đạt 78-100%, riêng lượt trợ lý 33%" và
  "Dựng bộ nhớ chiếm gần như toàn bộ thời gian".
- Slide 9: "Baseline chạy được, chưa đủ kết luận" thay cho "Tổng kết và
  bước tiếp"; rút ngắn để tiêu đề không xuống dòng đè lên chữ bên dưới.
- Bỏ các cụm mang giọng hướng dẫn: "Điểm cần nhớ" -> "Giới hạn quan trọng",
  "GHI LẠI ĐỂ KHỎI LẶP" -> "SỰ CỐ KỸ THUẬT", "BASELINE LÀ GÌ" ->
  "CÁCH HOẠT ĐỘNG", bỏ "đúng như dự đoán".
- Khoảng điểm trong tiêu đề slide 5 tính từ stats.json thay vì viết cứng.

Co-Authored-By: Claude Opus 5 <noreply@anthropic.com>
</commit_message>
<xml_diff>
--- a/baselines/bao-cao-lightmem-baseline.pptx
+++ b/baselines/bao-cao-lightmem-baseline.pptx
@@ -2448,7 +2448,7 @@
                 <a:ea typeface="Calibri" pitchFamily="34" charset="-122"/>
                 <a:cs typeface="Calibri" pitchFamily="34" charset="-120"/>
               </a:rPr>
-              <a:t>BASELINE LÀ GÌ</a:t>
+              <a:t>CÁCH HOẠT ĐỘNG</a:t>
             </a:r>
             <a:endParaRPr lang="en-US" sz="1100" dirty="0"/>
           </a:p>
@@ -3425,7 +3425,7 @@
                 <a:ea typeface="Calibri" pitchFamily="34" charset="-122"/>
                 <a:cs typeface="Calibri" pitchFamily="34" charset="-120"/>
               </a:rPr>
-              <a:t>Điểm cần nhớ</a:t>
+              <a:t>Giới hạn quan trọng</a:t>
             </a:r>
             <a:endParaRPr lang="en-US" sz="1250" dirty="0"/>
           </a:p>
@@ -4596,7 +4596,7 @@
                 <a:ea typeface="Cambria" pitchFamily="34" charset="-122"/>
                 <a:cs typeface="Cambria" pitchFamily="34" charset="-120"/>
               </a:rPr>
-              <a:t>Độ chính xác theo loại câu hỏi</a:t>
+              <a:t>Năm loại đạt 78–100%, riêng lượt trợ lý 33%</a:t>
             </a:r>
             <a:endParaRPr lang="en-US" sz="2600" dirty="0"/>
           </a:p>
@@ -7034,7 +7034,7 @@
                 <a:ea typeface="Calibri" pitchFamily="34" charset="-122"/>
                 <a:cs typeface="Calibri" pitchFamily="34" charset="-120"/>
               </a:rPr>
-              <a:t>Bằng chứng cho kiểu 2: </a:t>
+              <a:t>Bằng chứng: </a:t>
             </a:r>
             <a:pPr indent="0" marL="0">
               <a:buNone/>
@@ -7048,7 +7048,7 @@
                 <a:ea typeface="Calibri" pitchFamily="34" charset="-122"/>
                 <a:cs typeface="Calibri" pitchFamily="34" charset="-120"/>
               </a:rPr>
-              <a:t>4/6 câu sai loại lượt trợ lý, hệ trả lời thẳng là không tìm thấy thông tin trong bộ nhớ, đúng như dự đoán từ cấu hình user_only.</a:t>
+              <a:t>4/6 câu sai loại lượt trợ lý, hệ trả lời thẳng là không tìm thấy thông tin trong bộ nhớ, khớp với cấu hình user_only.</a:t>
             </a:r>
             <a:endParaRPr lang="en-US" sz="1050" dirty="0"/>
           </a:p>
@@ -7158,7 +7158,7 @@
                 <a:ea typeface="Cambria" pitchFamily="34" charset="-122"/>
                 <a:cs typeface="Cambria" pitchFamily="34" charset="-120"/>
               </a:rPr>
-              <a:t>Chi phí và thời gian</a:t>
+              <a:t>Dựng bộ nhớ chiếm gần như toàn bộ thời gian</a:t>
             </a:r>
             <a:endParaRPr lang="en-US" sz="2600" dirty="0"/>
           </a:p>
@@ -7683,7 +7683,7 @@
                 <a:ea typeface="Calibri" pitchFamily="34" charset="-122"/>
                 <a:cs typeface="Calibri" pitchFamily="34" charset="-120"/>
               </a:rPr>
-              <a:t>GHI LẠI ĐỂ KHỎI LẶP</a:t>
+              <a:t>SỰ CỐ KỸ THUẬT</a:t>
             </a:r>
             <a:endParaRPr lang="en-US" sz="1100" dirty="0"/>
           </a:p>
@@ -9029,8 +9029,8 @@
         </p:nvSpPr>
         <p:spPr>
           <a:xfrm>
-            <a:off x="640080" y="457200"/>
-            <a:ext cx="7863840" cy="640080"/>
+            <a:off x="640080" y="411480"/>
+            <a:ext cx="7863840" cy="685800"/>
           </a:xfrm>
           <a:prstGeom prst="rect">
             <a:avLst/>
@@ -9046,7 +9046,7 @@
               <a:buNone/>
             </a:pPr>
             <a:r>
-              <a:rPr lang="en-US" sz="3200" b="1" dirty="0">
+              <a:rPr lang="en-US" sz="3000" b="1" dirty="0">
                 <a:solidFill>
                   <a:srgbClr val="FFFFFF"/>
                 </a:solidFill>
@@ -9054,9 +9054,9 @@
                 <a:ea typeface="Cambria" pitchFamily="34" charset="-122"/>
                 <a:cs typeface="Cambria" pitchFamily="34" charset="-120"/>
               </a:rPr>
-              <a:t>Tổng kết và bước tiếp</a:t>
-            </a:r>
-            <a:endParaRPr lang="en-US" sz="3200" dirty="0"/>
+              <a:t>Baseline chạy được, chưa đủ kết luận</a:t>
+            </a:r>
+            <a:endParaRPr lang="en-US" sz="3000" dirty="0"/>
           </a:p>
         </p:txBody>
       </p:sp>
@@ -9093,7 +9093,7 @@
                 <a:ea typeface="Calibri" pitchFamily="34" charset="-122"/>
                 <a:cs typeface="Calibri" pitchFamily="34" charset="-120"/>
               </a:rPr>
-              <a:t>Tạm thời, mới 125/150 câu dev</a:t>
+              <a:t>Số liệu trên 125/150 câu dev</a:t>
             </a:r>
             <a:endParaRPr lang="en-US" sz="1400" dirty="0"/>
           </a:p>

</xml_diff>